<commit_message>
Publish Prooflane workspace and connected deployment
</commit_message>
<xml_diff>
--- a/docs/deliverables/technical-presentation.pptx
+++ b/docs/deliverables/technical-presentation.pptx
@@ -3130,7 +3130,7 @@
               </a:defRPr>
             </a:pPr>
             <a:r>
-              <a:t>SIH26155  /  CONFIGURATION AUDITOR</a:t>
+              <a:t>PROOFLANE  /  EVIDENCE CONSOLE</a:t>
             </a:r>
           </a:p>
         </p:txBody>
@@ -3200,7 +3200,7 @@
               </a:defRPr>
             </a:pPr>
             <a:r>
-              <a:t>SIH26155 / Multi-vendor network security compliance auditing</a:t>
+              <a:t>Prooflane / Multi-vendor network security compliance auditing</a:t>
             </a:r>
           </a:p>
         </p:txBody>
@@ -3436,7 +3436,7 @@
               </a:defRPr>
             </a:pPr>
             <a:r>
-              <a:t>SIH26155  /  CONFIGURATION AUDITOR</a:t>
+              <a:t>PROOFLANE  /  EVIDENCE CONSOLE</a:t>
             </a:r>
           </a:p>
         </p:txBody>
@@ -3777,7 +3777,7 @@
               </a:defRPr>
             </a:pPr>
             <a:r>
-              <a:t>SIH26155  /  CONFIGURATION AUDITOR</a:t>
+              <a:t>PROOFLANE  /  EVIDENCE CONSOLE</a:t>
             </a:r>
           </a:p>
         </p:txBody>
@@ -4118,7 +4118,7 @@
               </a:defRPr>
             </a:pPr>
             <a:r>
-              <a:t>SIH26155  /  CONFIGURATION AUDITOR</a:t>
+              <a:t>PROOFLANE  /  EVIDENCE CONSOLE</a:t>
             </a:r>
           </a:p>
         </p:txBody>
@@ -4363,7 +4363,7 @@
               </a:defRPr>
             </a:pPr>
             <a:r>
-              <a:t>• Throughput: 115.66 configs/min; metadata p95: 125.0 ms.</a:t>
+              <a:t>• 115.66 configs/min; one-hour metadata p95 32.0 ms (180000 successful reads).</a:t>
             </a:r>
           </a:p>
         </p:txBody>
@@ -4494,7 +4494,7 @@
               </a:defRPr>
             </a:pPr>
             <a:r>
-              <a:t>SIH26155  /  CONFIGURATION AUDITOR</a:t>
+              <a:t>PROOFLANE  /  EVIDENCE CONSOLE</a:t>
             </a:r>
           </a:p>
         </p:txBody>
@@ -4634,7 +4634,7 @@
               </a:defRPr>
             </a:pPr>
             <a:r>
-              <a:t>• Synthetic examples. The organizer supplied references, not a dataset.</a:t>
+              <a:t>• Synthetic examples; independently reviewed vendor labels remain future work.</a:t>
             </a:r>
           </a:p>
         </p:txBody>
@@ -4739,7 +4739,7 @@
               </a:defRPr>
             </a:pPr>
             <a:r>
-              <a:t>• Next evidence: expert labels, exact editions, operational checks and fair comparisons.</a:t>
+              <a:t>• Open: upstream image findings; expert labels, exact editions and fair comparisons.</a:t>
             </a:r>
           </a:p>
         </p:txBody>

</xml_diff>